<commit_message>
presentation: fix text fit on the approach slide and document slide geometry
Slide 3 had two boxes whose wrapped text was marginally taller than the shape
that held it: the methodology rows and the guardrail note under them. Give the
rows more height, move the guardrail card down and shorten its sentence so it
holds two lines with room to spare.

Add fit_audit.py, which estimates the wrapped height of every text box and
reports the ones that would overrun their shape or the slide. It measures with
DejaVu Sans rather than Calibri, so it errs on the side of reporting a problem.
The deck now audits clean.

Record the page setup in the README: 13.333in x 7.5in, 1280x720 at 96 dpi,
16:9 - the official template's own size, left unchanged.
</commit_message>
<xml_diff>
--- a/presentation/SIH2026_WellDrop_SENTRA_PS26165.pptx
+++ b/presentation/SIH2026_WellDrop_SENTRA_PS26165.pptx
@@ -8088,7 +8088,7 @@
         <p:spPr>
           <a:xfrm>
             <a:off x="6263640" y="3803904"/>
-            <a:ext cx="5532120" cy="402336"/>
+            <a:ext cx="5532120" cy="457200"/>
           </a:xfrm>
           <a:prstGeom prst="roundRect">
             <a:avLst>
@@ -8135,7 +8135,7 @@
         </p:nvSpPr>
         <p:spPr>
           <a:xfrm>
-            <a:off x="6373368" y="3886200"/>
+            <a:off x="6373368" y="3913632"/>
             <a:ext cx="237744" cy="237744"/>
           </a:xfrm>
           <a:prstGeom prst="ellipse">
@@ -8189,7 +8189,7 @@
         <p:spPr>
           <a:xfrm>
             <a:off x="6720840" y="3849624"/>
-            <a:ext cx="4965192" cy="310896"/>
+            <a:ext cx="4965192" cy="365760"/>
           </a:xfrm>
           <a:prstGeom prst="rect">
             <a:avLst/>
@@ -8236,8 +8236,8 @@
         </p:nvSpPr>
         <p:spPr>
           <a:xfrm>
-            <a:off x="6263640" y="4251960"/>
-            <a:ext cx="5532120" cy="402336"/>
+            <a:off x="6263640" y="4306824"/>
+            <a:ext cx="5532120" cy="457200"/>
           </a:xfrm>
           <a:prstGeom prst="roundRect">
             <a:avLst>
@@ -8284,7 +8284,7 @@
         </p:nvSpPr>
         <p:spPr>
           <a:xfrm>
-            <a:off x="6373368" y="4334256"/>
+            <a:off x="6373368" y="4416552"/>
             <a:ext cx="237744" cy="237744"/>
           </a:xfrm>
           <a:prstGeom prst="ellipse">
@@ -8337,8 +8337,8 @@
         </p:nvSpPr>
         <p:spPr>
           <a:xfrm>
-            <a:off x="6720840" y="4297680"/>
-            <a:ext cx="4965192" cy="310896"/>
+            <a:off x="6720840" y="4352544"/>
+            <a:ext cx="4965192" cy="365760"/>
           </a:xfrm>
           <a:prstGeom prst="rect">
             <a:avLst/>
@@ -8372,7 +8372,7 @@
                 </a:solidFill>
                 <a:latin typeface="Calibri"/>
               </a:rPr>
-              <a:t>zero-shot prototypes lift recall on paraphrase</a:t>
+              <a:t>zero-shot prototypes lift recall</a:t>
             </a:r>
           </a:p>
         </p:txBody>
@@ -8385,8 +8385,8 @@
         </p:nvSpPr>
         <p:spPr>
           <a:xfrm>
-            <a:off x="6263640" y="4700016"/>
-            <a:ext cx="5532120" cy="402336"/>
+            <a:off x="6263640" y="4809744"/>
+            <a:ext cx="5532120" cy="457200"/>
           </a:xfrm>
           <a:prstGeom prst="roundRect">
             <a:avLst>
@@ -8433,7 +8433,7 @@
         </p:nvSpPr>
         <p:spPr>
           <a:xfrm>
-            <a:off x="6373368" y="4782312"/>
+            <a:off x="6373368" y="4919472"/>
             <a:ext cx="237744" cy="237744"/>
           </a:xfrm>
           <a:prstGeom prst="ellipse">
@@ -8486,8 +8486,8 @@
         </p:nvSpPr>
         <p:spPr>
           <a:xfrm>
-            <a:off x="6720840" y="4745736"/>
-            <a:ext cx="4965192" cy="310896"/>
+            <a:off x="6720840" y="4855464"/>
+            <a:ext cx="4965192" cy="365760"/>
           </a:xfrm>
           <a:prstGeom prst="rect">
             <a:avLst/>
@@ -8534,8 +8534,8 @@
         </p:nvSpPr>
         <p:spPr>
           <a:xfrm>
-            <a:off x="6263640" y="5148072"/>
-            <a:ext cx="5532120" cy="402336"/>
+            <a:off x="6263640" y="5312664"/>
+            <a:ext cx="5532120" cy="457200"/>
           </a:xfrm>
           <a:prstGeom prst="roundRect">
             <a:avLst>
@@ -8582,7 +8582,7 @@
         </p:nvSpPr>
         <p:spPr>
           <a:xfrm>
-            <a:off x="6373368" y="5230368"/>
+            <a:off x="6373368" y="5422392"/>
             <a:ext cx="237744" cy="237744"/>
           </a:xfrm>
           <a:prstGeom prst="ellipse">
@@ -8635,8 +8635,8 @@
         </p:nvSpPr>
         <p:spPr>
           <a:xfrm>
-            <a:off x="6720840" y="5193792"/>
-            <a:ext cx="4965192" cy="310896"/>
+            <a:off x="6720840" y="5358383"/>
+            <a:ext cx="4965192" cy="365760"/>
           </a:xfrm>
           <a:prstGeom prst="rect">
             <a:avLst/>
@@ -8683,7 +8683,7 @@
         </p:nvSpPr>
         <p:spPr>
           <a:xfrm>
-            <a:off x="6263640" y="5596128"/>
+            <a:off x="6263640" y="5797296"/>
             <a:ext cx="5532120" cy="566928"/>
           </a:xfrm>
           <a:prstGeom prst="roundRect">
@@ -8731,7 +8731,7 @@
         </p:nvSpPr>
         <p:spPr>
           <a:xfrm>
-            <a:off x="6409944" y="5669280"/>
+            <a:off x="6409944" y="5870448"/>
             <a:ext cx="5239512" cy="457200"/>
           </a:xfrm>
           <a:prstGeom prst="rect">
@@ -8766,7 +8766,7 @@
                 </a:solidFill>
                 <a:latin typeface="Calibri"/>
               </a:rPr>
-              <a:t>if an encoder scores every prototype alike, its ranking is ignored and the rules decide — verified against a deliberately degenerate model.</a:t>
+              <a:t>if an encoder scores every prototype alike, its ranking is ignored and the rules decide.</a:t>
             </a:r>
           </a:p>
         </p:txBody>

</xml_diff>